<commit_message>
Few Changes Made (8-2-2026)
</commit_message>
<xml_diff>
--- a/Diabetes Diagnostic Tool/Diabetes Prediction.pptx
+++ b/Diabetes Diagnostic Tool/Diabetes Prediction.pptx
@@ -2981,8 +2981,8 @@
         </p:nvSpPr>
         <p:spPr>
           <a:xfrm>
-            <a:off x="914400" y="1642004"/>
-            <a:ext cx="7620000" cy="1154112"/>
+            <a:off x="914400" y="1489605"/>
+            <a:ext cx="7381568" cy="3185634"/>
           </a:xfrm>
           <a:prstGeom prst="rect">
             <a:avLst/>
@@ -2994,67 +2994,188 @@
           <a:bodyPr wrap="square" lIns="0" tIns="0" rIns="0" bIns="0" rtlCol="0" anchor="t"/>
           <a:lstStyle/>
           <a:p>
-            <a:pPr marL="342900" indent="-342900">
-              <a:lnSpc>
-                <a:spcPts val="2430"/>
-              </a:lnSpc>
-              <a:buSzPct val="100000"/>
-              <a:buChar char="•"/>
-            </a:pPr>
             <a:r>
               <a:rPr lang="en-US" sz="1350" dirty="0">
                 <a:solidFill>
                   <a:srgbClr val="CBD5E1"/>
                 </a:solidFill>
                 <a:latin typeface="Arial" pitchFamily="34" charset="0"/>
-                <a:ea typeface="Arial" pitchFamily="34" charset="-122"/>
-                <a:cs typeface="Arial" pitchFamily="34" charset="-120"/>
-              </a:rPr>
-              <a:t>Accuracy: ~75-78% (balanced performance)</a:t>
-            </a:r>
-            <a:endParaRPr lang="en-US" sz="1350" dirty="0"/>
-          </a:p>
-          <a:p>
-            <a:pPr marL="342900" indent="-342900">
-              <a:lnSpc>
-                <a:spcPts val="2430"/>
-              </a:lnSpc>
-              <a:buSzPct val="100000"/>
-              <a:buChar char="•"/>
-            </a:pPr>
-            <a:r>
+                <a:cs typeface="Arial" pitchFamily="34" charset="-120"/>
+              </a:rPr>
+              <a:t>Model: Logistic Regression</a:t>
+            </a:r>
+            <a:br>
               <a:rPr lang="en-US" sz="1350" dirty="0">
                 <a:solidFill>
                   <a:srgbClr val="CBD5E1"/>
                 </a:solidFill>
                 <a:latin typeface="Arial" pitchFamily="34" charset="0"/>
-                <a:ea typeface="Arial" pitchFamily="34" charset="-122"/>
-                <a:cs typeface="Arial" pitchFamily="34" charset="-120"/>
-              </a:rPr>
-              <a:t>Recall: ~70-80% (catches most diabetic cases)</a:t>
-            </a:r>
-            <a:endParaRPr lang="en-US" sz="1350" dirty="0"/>
-          </a:p>
-          <a:p>
-            <a:pPr marL="342900" indent="-342900">
-              <a:lnSpc>
-                <a:spcPts val="2430"/>
-              </a:lnSpc>
-              <a:buSzPct val="100000"/>
-              <a:buChar char="•"/>
-            </a:pPr>
+                <a:cs typeface="Arial" pitchFamily="34" charset="-120"/>
+              </a:rPr>
+            </a:br>
             <a:r>
               <a:rPr lang="en-US" sz="1350" dirty="0">
                 <a:solidFill>
                   <a:srgbClr val="CBD5E1"/>
                 </a:solidFill>
                 <a:latin typeface="Arial" pitchFamily="34" charset="0"/>
-                <a:ea typeface="Arial" pitchFamily="34" charset="-122"/>
-                <a:cs typeface="Arial" pitchFamily="34" charset="-120"/>
-              </a:rPr>
-              <a:t>AUC: ~0.80-0.85 (good discrimination ability)</a:t>
-            </a:r>
-            <a:endParaRPr lang="en-US" sz="1350" dirty="0"/>
+                <a:cs typeface="Arial" pitchFamily="34" charset="-120"/>
+              </a:rPr>
+              <a:t>Tuning: </a:t>
+            </a:r>
+            <a:r>
+              <a:rPr lang="en-US" sz="1350" dirty="0" err="1">
+                <a:solidFill>
+                  <a:srgbClr val="CBD5E1"/>
+                </a:solidFill>
+                <a:latin typeface="Arial" pitchFamily="34" charset="0"/>
+                <a:cs typeface="Arial" pitchFamily="34" charset="-120"/>
+              </a:rPr>
+              <a:t>GridSearchCV</a:t>
+            </a:r>
+            <a:r>
+              <a:rPr lang="en-US" sz="1350" dirty="0">
+                <a:solidFill>
+                  <a:srgbClr val="CBD5E1"/>
+                </a:solidFill>
+                <a:latin typeface="Arial" pitchFamily="34" charset="0"/>
+                <a:cs typeface="Arial" pitchFamily="34" charset="-120"/>
+              </a:rPr>
+              <a:t> (C parameter)</a:t>
+            </a:r>
+          </a:p>
+          <a:p>
+            <a:r>
+              <a:rPr lang="en-US" sz="1350" dirty="0">
+                <a:solidFill>
+                  <a:srgbClr val="CBD5E1"/>
+                </a:solidFill>
+                <a:latin typeface="Arial" pitchFamily="34" charset="0"/>
+                <a:cs typeface="Arial" pitchFamily="34" charset="-120"/>
+              </a:rPr>
+              <a:t>Default Threshold: 0.50</a:t>
+            </a:r>
+            <a:br>
+              <a:rPr lang="en-US" sz="1350" dirty="0">
+                <a:solidFill>
+                  <a:srgbClr val="CBD5E1"/>
+                </a:solidFill>
+                <a:latin typeface="Arial" pitchFamily="34" charset="0"/>
+                <a:cs typeface="Arial" pitchFamily="34" charset="-120"/>
+              </a:rPr>
+            </a:br>
+            <a:r>
+              <a:rPr lang="en-US" sz="1350" dirty="0">
+                <a:solidFill>
+                  <a:srgbClr val="CBD5E1"/>
+                </a:solidFill>
+                <a:latin typeface="Arial" pitchFamily="34" charset="0"/>
+                <a:cs typeface="Arial" pitchFamily="34" charset="-120"/>
+              </a:rPr>
+              <a:t>Best Threshold: 0.25 (F1 optimized)</a:t>
+            </a:r>
+          </a:p>
+          <a:p>
+            <a:r>
+              <a:rPr lang="en-US" sz="1350" dirty="0">
+                <a:solidFill>
+                  <a:srgbClr val="CBD5E1"/>
+                </a:solidFill>
+                <a:latin typeface="Arial" pitchFamily="34" charset="0"/>
+                <a:cs typeface="Arial" pitchFamily="34" charset="-120"/>
+              </a:rPr>
+              <a:t>Final Performance:</a:t>
+            </a:r>
+          </a:p>
+          <a:p>
+            <a:endParaRPr lang="en-US" sz="1350" dirty="0">
+              <a:solidFill>
+                <a:srgbClr val="CBD5E1"/>
+              </a:solidFill>
+              <a:latin typeface="Arial" pitchFamily="34" charset="0"/>
+              <a:cs typeface="Arial" pitchFamily="34" charset="-120"/>
+            </a:endParaRPr>
+          </a:p>
+          <a:p>
+            <a:r>
+              <a:rPr lang="en-US" sz="1350" dirty="0">
+                <a:solidFill>
+                  <a:srgbClr val="CBD5E1"/>
+                </a:solidFill>
+                <a:latin typeface="Arial" pitchFamily="34" charset="0"/>
+                <a:cs typeface="Arial" pitchFamily="34" charset="-120"/>
+              </a:rPr>
+              <a:t>Accuracy: 76.7%</a:t>
+            </a:r>
+          </a:p>
+          <a:p>
+            <a:r>
+              <a:rPr lang="en-US" sz="1350" dirty="0">
+                <a:solidFill>
+                  <a:srgbClr val="CBD5E1"/>
+                </a:solidFill>
+                <a:latin typeface="Arial" pitchFamily="34" charset="0"/>
+                <a:cs typeface="Arial" pitchFamily="34" charset="-120"/>
+              </a:rPr>
+              <a:t>Precision: 62.5%</a:t>
+            </a:r>
+          </a:p>
+          <a:p>
+            <a:r>
+              <a:rPr lang="en-US" sz="1350" dirty="0">
+                <a:solidFill>
+                  <a:srgbClr val="CBD5E1"/>
+                </a:solidFill>
+                <a:latin typeface="Arial" pitchFamily="34" charset="0"/>
+                <a:cs typeface="Arial" pitchFamily="34" charset="-120"/>
+              </a:rPr>
+              <a:t>Recall: 85.4%</a:t>
+            </a:r>
+          </a:p>
+          <a:p>
+            <a:r>
+              <a:rPr lang="en-US" sz="1350" dirty="0">
+                <a:solidFill>
+                  <a:srgbClr val="CBD5E1"/>
+                </a:solidFill>
+                <a:latin typeface="Arial" pitchFamily="34" charset="0"/>
+                <a:cs typeface="Arial" pitchFamily="34" charset="-120"/>
+              </a:rPr>
+              <a:t>F1 Score: 0.72</a:t>
+            </a:r>
+          </a:p>
+          <a:p>
+            <a:endParaRPr lang="en-US" sz="1350" dirty="0">
+              <a:solidFill>
+                <a:srgbClr val="CBD5E1"/>
+              </a:solidFill>
+              <a:latin typeface="Arial" pitchFamily="34" charset="0"/>
+              <a:cs typeface="Arial" pitchFamily="34" charset="-120"/>
+            </a:endParaRPr>
+          </a:p>
+          <a:p>
+            <a:r>
+              <a:rPr lang="en-US" sz="1350" dirty="0">
+                <a:solidFill>
+                  <a:srgbClr val="CBD5E1"/>
+                </a:solidFill>
+                <a:latin typeface="Arial" pitchFamily="34" charset="0"/>
+                <a:cs typeface="Arial" pitchFamily="34" charset="-120"/>
+              </a:rPr>
+              <a:t>Insight</a:t>
+            </a:r>
+          </a:p>
+          <a:p>
+            <a:r>
+              <a:rPr lang="en-US" sz="1350" dirty="0">
+                <a:solidFill>
+                  <a:srgbClr val="CBD5E1"/>
+                </a:solidFill>
+                <a:latin typeface="Arial" pitchFamily="34" charset="0"/>
+                <a:cs typeface="Arial" pitchFamily="34" charset="-120"/>
+              </a:rPr>
+              <a:t>Threshold tuning significantly improved diabetic detection while maintaining acceptable precision.</a:t>
+            </a:r>
           </a:p>
         </p:txBody>
       </p:sp>

</xml_diff>

<commit_message>
Few Changes made ( 8-2-2026 )
</commit_message>
<xml_diff>
--- a/Diabetes Diagnostic Tool/Diabetes Prediction.pptx
+++ b/Diabetes Diagnostic Tool/Diabetes Prediction.pptx
@@ -2939,7 +2939,7 @@
         </p:nvSpPr>
         <p:spPr>
           <a:xfrm>
-            <a:off x="609600" y="1249628"/>
+            <a:off x="609600" y="1009651"/>
             <a:ext cx="8083296" cy="239977"/>
           </a:xfrm>
           <a:prstGeom prst="rect">
@@ -2981,8 +2981,8 @@
         </p:nvSpPr>
         <p:spPr>
           <a:xfrm>
-            <a:off x="914400" y="1489605"/>
-            <a:ext cx="7381568" cy="3185634"/>
+            <a:off x="914400" y="1306725"/>
+            <a:ext cx="7381568" cy="3420020"/>
           </a:xfrm>
           <a:prstGeom prst="rect">
             <a:avLst/>
@@ -3175,6 +3175,27 @@
                 <a:cs typeface="Arial" pitchFamily="34" charset="-120"/>
               </a:rPr>
               <a:t>Threshold tuning significantly improved diabetic detection while maintaining acceptable precision.</a:t>
+            </a:r>
+          </a:p>
+          <a:p>
+            <a:endParaRPr lang="en-US" sz="1350" dirty="0">
+              <a:solidFill>
+                <a:srgbClr val="CBD5E1"/>
+              </a:solidFill>
+              <a:latin typeface="Arial" pitchFamily="34" charset="0"/>
+              <a:cs typeface="Arial" pitchFamily="34" charset="-120"/>
+            </a:endParaRPr>
+          </a:p>
+          <a:p>
+            <a:r>
+              <a:rPr lang="en-US" sz="1350" dirty="0">
+                <a:solidFill>
+                  <a:srgbClr val="CBD5E1"/>
+                </a:solidFill>
+                <a:latin typeface="Arial" pitchFamily="34" charset="0"/>
+                <a:cs typeface="Arial" pitchFamily="34" charset="-120"/>
+              </a:rPr>
+              <a:t>Lower precision is acceptable because in medical screening (like diabetes), it’s more important to catch as many true patients as possible (high recall), even if it means some healthy people are falsely flagged.</a:t>
             </a:r>
           </a:p>
         </p:txBody>

</xml_diff>